<commit_message>
Rebuild the deck on the completed label set
Classification finished the backlog - 41,691 descriptions - and the final
scoring pass folded all of them in: 43,256 works out of "Other", leaving
7,464. Queue 47,719, HIGH 2,287, 912 detector findings.

Figures come from figures(), so this is a rebuild rather than a retype.

Co-Authored-By: Claude Opus 5 <noreply@anthropic.com>
</commit_message>
<xml_diff>
--- a/docs/deck/SIH26102-MPLADS-SIH-Idea.pptx
+++ b/docs/deck/SIH26102-MPLADS-SIH-Idea.pptx
@@ -7149,7 +7149,7 @@
                 </a:solidFill>
                 <a:latin typeface="Calibri"/>
               </a:rPr>
-              <a:t>A jeweller rubs gold against a kasauti and reads the streak: the stone says which pieces are worth assaying, never which are false. This reads the published MPLADS record end to end and scores every work against comparable works in the same district and sector. 47,471 clear the review threshold, carrying Rs 4,602 Cr of sanction. Officials get them ranked, not a spreadsheet.</a:t>
+              <a:t>A jeweller rubs gold against a kasauti and reads the streak: the stone says which pieces are worth assaying, never which are false. This reads the published MPLADS record end to end and scores every work against comparable works in the same district and sector. 47,719 clear the review threshold, carrying Rs 4,609 Cr of sanction. Officials get them ranked, not a spreadsheet.</a:t>
             </a:r>
           </a:p>
         </p:txBody>
@@ -8459,7 +8459,7 @@
               </a:rPr>
               <a:t>Vercel, two projects
 GitHub Actions nightly
-127 automated tests
+129 automated tests
 Live since day one</a:t>
             </a:r>
           </a:p>
@@ -10303,7 +10303,7 @@
                 </a:solidFill>
                 <a:latin typeface="Calibri"/>
               </a:rPr>
-              <a:t>Not a proposal - already built, deployed and refreshing nightly: 250,839 works scored, all 36 states reconciled against the official MoSPI dashboard to within 3.6%, live at mplads-risk-monitor-web.vercel.app</a:t>
+              <a:t>Not a proposal - already built, deployed and refreshing nightly: 250,839 works scored, all 36 states reconciled against the official MoSPI dashboard to within 3.8%, live at mplads-risk-monitor-web.vercel.app</a:t>
             </a:r>
           </a:p>
         </p:txBody>
@@ -10475,7 +10475,7 @@
                 </a:solidFill>
                 <a:latin typeface="Calibri"/>
               </a:rPr>
-              <a:t>The data is already public and machine-readable: four CSVs, refreshed nightly by a scheduled job that loads in 2 minutes and scores in about 20. No ministry integration, no new reporting burden on any officer, no hardware. 127 automated tests run against the pipeline and the API.</a:t>
+              <a:t>The data is already public and machine-readable: four CSVs, refreshed nightly by a scheduled job that loads in 2 minutes and scores in about 20. No ministry integration, no new reporting burden on any officer, no hardware. 129 automated tests run against the pipeline and the API.</a:t>
             </a:r>
           </a:p>
         </p:txBody>
@@ -11546,7 +11546,7 @@
                 </a:solidFill>
                 <a:latin typeface="Consolas"/>
               </a:rPr>
-              <a:t>47,471</a:t>
+              <a:t>47,719</a:t>
             </a:r>
           </a:p>
         </p:txBody>
@@ -11672,7 +11672,7 @@
                 </a:solidFill>
                 <a:latin typeface="Consolas"/>
               </a:rPr>
-              <a:t>Rs 4,602 Cr</a:t>
+              <a:t>Rs 4,609 Cr</a:t>
             </a:r>
           </a:p>
         </p:txBody>
@@ -13152,7 +13152,7 @@
               </a:rPr>
               <a:t>The problem statement names mplads.mospi.gov.in. Its public interface, enumerated from its own JavaScript and called directly: totals, states, districts and member names are open to anyone. Works are not. Completed works come only through a citizen rating form that needs an SMS one-time password on an Indian mobile, returns one member's works in one ward per call, and is rate limited. Recommended works, payments and vendors are not served at all; every other path answers 302 to the login page.
 Empowered Indian republishes that record as machine-readable exports. Its own uploader reads the State Bank disbursement portal that MPLADS money is paid through, with a signed-in session cookie at one request every three seconds.
-So this system loads those exports - 250,839 works, 272,263 payments, 1,547 MP-terms, 776 districts, 62,969 vendors - and reconciles against the official endpoints on every refresh: five figures within 3.6%, every gap negative because our snapshot trails a portal that gains works overnight. 4,789 rows rejected and recorded, not silently dropped.</a:t>
+So this system loads those exports - 250,839 works, 272,263 payments, 1,547 MP-terms, 776 districts, 62,969 vendors - and reconciles against the official endpoints on every refresh: five figures within 3.8%, every gap negative because our snapshot trails a portal that gains works overnight. 5,623 rows rejected and recorded, not silently dropped.</a:t>
             </a:r>
           </a:p>
         </p:txBody>

</xml_diff>

<commit_message>
Scope the deck's reject count to the extract it sits beside
The slide read "1,488 rows rejected and recorded, not silently dropped"
next to this load's 250,839 works, because the figure counted every run
ever recorded rather than the one being described. The latest extract
rejected 417.

Same conflation as the provenance page, and it only became visible after
rejected_rows stopped double-counting - before that the number was wrong
in two directions at once.

Co-Authored-By: Claude Opus 5 <noreply@anthropic.com>
</commit_message>
<xml_diff>
--- a/docs/deck/SIH26102-MPLADS-SIH-Idea.pptx
+++ b/docs/deck/SIH26102-MPLADS-SIH-Idea.pptx
@@ -8459,7 +8459,7 @@
               </a:rPr>
               <a:t>Vercel, two projects
 GitHub Actions nightly
-129 automated tests
+132 automated tests
 Live since day one</a:t>
             </a:r>
           </a:p>
@@ -10475,7 +10475,7 @@
                 </a:solidFill>
                 <a:latin typeface="Calibri"/>
               </a:rPr>
-              <a:t>The data is already public and machine-readable: four CSVs, refreshed nightly by a scheduled job that loads in 2 minutes and scores in about 20. No ministry integration, no new reporting burden on any officer, no hardware. 129 automated tests run against the pipeline and the API.</a:t>
+              <a:t>The data is already public and machine-readable: four CSVs, refreshed nightly by a scheduled job that loads in 2 minutes and scores in about 20. No ministry integration, no new reporting burden on any officer, no hardware. 132 automated tests run against the pipeline and the API.</a:t>
             </a:r>
           </a:p>
         </p:txBody>
@@ -13125,7 +13125,7 @@
         <p:spPr>
           <a:xfrm>
             <a:off x="813816" y="2217928"/>
-            <a:ext cx="5029200" cy="2788920"/>
+            <a:ext cx="5029200" cy="2633980"/>
           </a:xfrm>
           <a:prstGeom prst="rect">
             <a:avLst/>
@@ -13152,7 +13152,7 @@
               </a:rPr>
               <a:t>The problem statement names mplads.mospi.gov.in. Its public interface, enumerated from its own JavaScript and called directly: totals, states, districts and member names are open to anyone. Works are not. Completed works come only through a citizen rating form that needs an SMS one-time password on an Indian mobile, returns one member's works in one ward per call, and is rate limited. Recommended works, payments and vendors are not served at all; every other path answers 302 to the login page.
 Empowered Indian republishes that record as machine-readable exports. Its own uploader reads the State Bank disbursement portal that MPLADS money is paid through, with a signed-in session cookie at one request every three seconds.
-So this system loads those exports - 250,839 works, 272,263 payments, 1,547 MP-terms, 776 districts, 62,969 vendors - and reconciles against the official endpoints on every refresh: five figures within 3.8%, every gap negative because our snapshot trails a portal that gains works overnight. 5,623 rows rejected and recorded, not silently dropped.</a:t>
+So this system loads those exports - 250,839 works, 272,263 payments, 1,547 MP-terms, 776 districts, 62,969 vendors - and reconciles against the official endpoints on every refresh: five figures within 3.8%, every gap negative because our snapshot trails a portal that gains works overnight. 417 rows rejected and recorded, not silently dropped.</a:t>
             </a:r>
           </a:p>
         </p:txBody>

</xml_diff>

<commit_message>
Rebuild the deck after the audit fixes
The suite is 136 tests now, and figures() reads it at build time.

Co-Authored-By: Claude Opus 5 <noreply@anthropic.com>
</commit_message>
<xml_diff>
--- a/docs/deck/SIH26102-MPLADS-SIH-Idea.pptx
+++ b/docs/deck/SIH26102-MPLADS-SIH-Idea.pptx
@@ -8459,7 +8459,7 @@
               </a:rPr>
               <a:t>Vercel, two projects
 GitHub Actions nightly
-132 automated tests
+136 automated tests
 Live since day one</a:t>
             </a:r>
           </a:p>
@@ -10475,7 +10475,7 @@
                 </a:solidFill>
                 <a:latin typeface="Calibri"/>
               </a:rPr>
-              <a:t>The data is already public and machine-readable: four CSVs, refreshed nightly by a scheduled job that loads in 2 minutes and scores in about 20. No ministry integration, no new reporting burden on any officer, no hardware. 132 automated tests run against the pipeline and the API.</a:t>
+              <a:t>The data is already public and machine-readable: four CSVs, refreshed nightly by a scheduled job that loads in 2 minutes and scores in about 20. No ministry integration, no new reporting burden on any officer, no hardware. 136 automated tests run against the pipeline and the API.</a:t>
             </a:r>
           </a:p>
         </p:txBody>

</xml_diff>